<commit_message>
added repo to report, presentation, fixed some code
</commit_message>
<xml_diff>
--- a/report/presentation/FinWatch_Final_Presentation.pptx
+++ b/report/presentation/FinWatch_Final_Presentation.pptx
@@ -2778,6 +2778,58 @@
               <a:t>1</a:t>
             </a:r>
             <a:endParaRPr lang="en-US" sz="1000" dirty="0"/>
+          </a:p>
+        </p:txBody>
+      </p:sp>
+      <p:sp>
+        <p:nvSpPr>
+          <p:cNvPr id="10" name="תיבת טקסט 9">
+            <a:extLst>
+              <a:ext uri="{FF2B5EF4-FFF2-40B4-BE49-F238E27FC236}">
+                <a16:creationId xmlns:a16="http://schemas.microsoft.com/office/drawing/2014/main" id="{2DF93969-32F3-4360-8122-6DB63C1148FD}"/>
+              </a:ext>
+            </a:extLst>
+          </p:cNvPr>
+          <p:cNvSpPr txBox="1"/>
+          <p:nvPr/>
+        </p:nvSpPr>
+        <p:spPr>
+          <a:xfrm>
+            <a:off x="6800294" y="5734288"/>
+            <a:ext cx="5294078" cy="369332"/>
+          </a:xfrm>
+          <a:prstGeom prst="rect">
+            <a:avLst/>
+          </a:prstGeom>
+          <a:noFill/>
+        </p:spPr>
+        <p:txBody>
+          <a:bodyPr wrap="none" rtlCol="1">
+            <a:spAutoFit/>
+          </a:bodyPr>
+          <a:lstStyle/>
+          <a:p>
+            <a:r>
+              <a:rPr lang="en-US" dirty="0" err="1">
+                <a:solidFill>
+                  <a:schemeClr val="bg1"/>
+                </a:solidFill>
+              </a:rPr>
+              <a:t>Github</a:t>
+            </a:r>
+            <a:r>
+              <a:rPr lang="en-US" dirty="0">
+                <a:solidFill>
+                  <a:schemeClr val="bg1"/>
+                </a:solidFill>
+              </a:rPr>
+              <a:t> Repo: https://github.com/laserblade41/FinProj</a:t>
+            </a:r>
+            <a:endParaRPr lang="he-IL" dirty="0">
+              <a:solidFill>
+                <a:schemeClr val="bg1"/>
+              </a:solidFill>
+            </a:endParaRPr>
           </a:p>
         </p:txBody>
       </p:sp>

</xml_diff>